<commit_message>
evidence: record latest acceptance fail state
</commit_message>
<xml_diff>
--- a/packaging/templates/FPAMonthEndCopilot_v1.pptx
+++ b/packaging/templates/FPAMonthEndCopilot_v1.pptx
@@ -109,11 +109,15 @@
 <c:chartSpace xmlns:c="http://schemas.openxmlformats.org/drawingml/2006/chart" xmlns:a="http://schemas.openxmlformats.org/drawingml/2006/main" xmlns:r="http://schemas.openxmlformats.org/officeDocument/2006/relationships">
   <c:date1904 val="0"/>
   <c:chart>
+    <c:title>
+      <c:layout/>
+      <c:overlay val="0"/>
+    </c:title>
     <c:autoTitleDeleted val="0"/>
     <c:plotArea>
       <c:barChart>
-        <c:barDir val="bar"/>
-        <c:grouping val="clustered"/>
+        <c:barDir val="col"/>
+        <c:grouping val="stacked"/>
         <c:ser>
           <c:idx val="0"/>
           <c:order val="0"/>
@@ -123,11 +127,17 @@
               <c:strCache>
                 <c:ptCount val="1"/>
                 <c:pt idx="0">
-                  <c:v>Series 1</c:v>
+                  <c:v>base</c:v>
                 </c:pt>
               </c:strCache>
             </c:strRef>
           </c:tx>
+          <c:spPr>
+            <a:noFill/>
+            <a:ln>
+              <a:noFill/>
+            </a:ln>
+          </c:spPr>
           <c:cat>
             <c:strRef>
               <c:f>Sheet1!$A$2:$A$2</c:f>
@@ -152,6 +162,50 @@
             </c:numRef>
           </c:val>
         </c:ser>
+        <c:ser>
+          <c:idx val="1"/>
+          <c:order val="1"/>
+          <c:tx>
+            <c:strRef>
+              <c:f>Sheet1!$C$1</c:f>
+              <c:strCache>
+                <c:ptCount val="1"/>
+                <c:pt idx="0">
+                  <c:v>amount</c:v>
+                </c:pt>
+              </c:strCache>
+            </c:strRef>
+          </c:tx>
+          <c:spPr>
+            <a:solidFill>
+              <a:srgbClr val="1F3A5F"/>
+            </a:solidFill>
+          </c:spPr>
+          <c:cat>
+            <c:strRef>
+              <c:f>Sheet1!$A$2:$A$2</c:f>
+              <c:strCache>
+                <c:ptCount val="1"/>
+                <c:pt idx="0">
+                  <c:v>Template</c:v>
+                </c:pt>
+              </c:strCache>
+            </c:strRef>
+          </c:cat>
+          <c:val>
+            <c:numRef>
+              <c:f>Sheet1!$C$2:$C$2</c:f>
+              <c:numCache>
+                <c:formatCode>General</c:formatCode>
+                <c:ptCount val="1"/>
+                <c:pt idx="0">
+                  <c:v>0.0</c:v>
+                </c:pt>
+              </c:numCache>
+            </c:numRef>
+          </c:val>
+        </c:ser>
+        <c:overlap val="100"/>
         <c:axId val="-2068027336"/>
         <c:axId val="-2113994440"/>
       </c:barChart>
@@ -161,7 +215,7 @@
           <c:orientation val="minMax"/>
         </c:scaling>
         <c:delete val="0"/>
-        <c:axPos val="l"/>
+        <c:axPos val="b"/>
         <c:majorTickMark val="out"/>
         <c:minorTickMark val="none"/>
         <c:tickLblPos val="nextTo"/>
@@ -176,7 +230,7 @@
         <c:axId val="-2113994440"/>
         <c:scaling/>
         <c:delete val="0"/>
-        <c:axPos val="b"/>
+        <c:axPos val="l"/>
         <c:majorGridlines/>
         <c:majorTickMark val="out"/>
         <c:minorTickMark val="none"/>
@@ -207,6 +261,10 @@
 <c:chartSpace xmlns:c="http://schemas.openxmlformats.org/drawingml/2006/chart" xmlns:a="http://schemas.openxmlformats.org/drawingml/2006/main" xmlns:r="http://schemas.openxmlformats.org/officeDocument/2006/relationships">
   <c:date1904 val="0"/>
   <c:chart>
+    <c:title>
+      <c:layout/>
+      <c:overlay val="0"/>
+    </c:title>
     <c:autoTitleDeleted val="0"/>
     <c:plotArea>
       <c:lineChart>
@@ -221,11 +279,18 @@
               <c:strCache>
                 <c:ptCount val="1"/>
                 <c:pt idx="0">
-                  <c:v>Series 1</c:v>
+                  <c:v>Actual</c:v>
                 </c:pt>
               </c:strCache>
             </c:strRef>
           </c:tx>
+          <c:spPr>
+            <a:ln>
+              <a:solidFill>
+                <a:srgbClr val="1F3A5F"/>
+              </a:solidFill>
+            </a:ln>
+          </c:spPr>
           <c:cat>
             <c:strRef>
               <c:f>Sheet1!$A$2:$A$2</c:f>
@@ -240,6 +305,99 @@
           <c:val>
             <c:numRef>
               <c:f>Sheet1!$B$2:$B$2</c:f>
+              <c:numCache>
+                <c:formatCode>General</c:formatCode>
+                <c:ptCount val="1"/>
+                <c:pt idx="0">
+                  <c:v>0.0</c:v>
+                </c:pt>
+              </c:numCache>
+            </c:numRef>
+          </c:val>
+          <c:smooth val="0"/>
+        </c:ser>
+        <c:ser>
+          <c:idx val="1"/>
+          <c:order val="1"/>
+          <c:tx>
+            <c:strRef>
+              <c:f>Sheet1!$C$1</c:f>
+              <c:strCache>
+                <c:ptCount val="1"/>
+                <c:pt idx="0">
+                  <c:v>Forecast</c:v>
+                </c:pt>
+              </c:strCache>
+            </c:strRef>
+          </c:tx>
+          <c:spPr>
+            <a:ln>
+              <a:solidFill>
+                <a:srgbClr val="B7791F"/>
+              </a:solidFill>
+            </a:ln>
+          </c:spPr>
+          <c:cat>
+            <c:strRef>
+              <c:f>Sheet1!$A$2:$A$2</c:f>
+              <c:strCache>
+                <c:ptCount val="1"/>
+                <c:pt idx="0">
+                  <c:v>Template</c:v>
+                </c:pt>
+              </c:strCache>
+            </c:strRef>
+          </c:cat>
+          <c:val>
+            <c:numRef>
+              <c:f>Sheet1!$C$2:$C$2</c:f>
+              <c:numCache>
+                <c:formatCode>General</c:formatCode>
+                <c:ptCount val="1"/>
+                <c:pt idx="0">
+                  <c:v>0.0</c:v>
+                </c:pt>
+              </c:numCache>
+            </c:numRef>
+          </c:val>
+          <c:smooth val="0"/>
+        </c:ser>
+        <c:ser>
+          <c:idx val="2"/>
+          <c:order val="2"/>
+          <c:tx>
+            <c:strRef>
+              <c:f>Sheet1!$D$1</c:f>
+              <c:strCache>
+                <c:ptCount val="1"/>
+                <c:pt idx="0">
+                  <c:v>Budget</c:v>
+                </c:pt>
+              </c:strCache>
+            </c:strRef>
+          </c:tx>
+          <c:spPr>
+            <a:ln>
+              <a:solidFill>
+                <a:srgbClr val="9CA3AF"/>
+              </a:solidFill>
+              <a:prstDash val="sysDot"/>
+            </a:ln>
+          </c:spPr>
+          <c:cat>
+            <c:strRef>
+              <c:f>Sheet1!$A$2:$A$2</c:f>
+              <c:strCache>
+                <c:ptCount val="1"/>
+                <c:pt idx="0">
+                  <c:v>Template</c:v>
+                </c:pt>
+              </c:strCache>
+            </c:strRef>
+          </c:cat>
+          <c:val>
+            <c:numRef>
+              <c:f>Sheet1!$D$2:$D$2</c:f>
               <c:numCache>
                 <c:formatCode>General</c:formatCode>
                 <c:ptCount val="1"/>
@@ -287,7 +445,7 @@
       </c:valAx>
     </c:plotArea>
     <c:legend>
-      <c:legendPos val="r"/>
+      <c:legendPos val="b"/>
       <c:layout/>
       <c:overlay val="0"/>
     </c:legend>
@@ -2414,7 +2572,7 @@
         </p:nvGraphicFramePr>
         <p:xfrm>
           <a:off x="411480" y="1325880"/>
-          <a:ext cx="11365992" cy="3291834"/>
+          <a:ext cx="11365992" cy="3291840"/>
         </p:xfrm>
         <a:graphic>
           <a:graphicData uri="http://schemas.openxmlformats.org/drawingml/2006/table">
@@ -2431,7 +2589,7 @@
                 <a:gridCol w="914400"/>
                 <a:gridCol w="2221992"/>
               </a:tblGrid>
-              <a:tr h="470262">
+              <a:tr h="548640">
                 <a:tc>
                   <a:txBody>
                     <a:bodyPr wrap="square"/>
@@ -2594,7 +2752,7 @@
                   </a:tcPr>
                 </a:tc>
               </a:tr>
-              <a:tr h="470262">
+              <a:tr h="548640">
                 <a:tc>
                   <a:txBody>
                     <a:bodyPr wrap="square"/>
@@ -2757,7 +2915,7 @@
                   </a:tcPr>
                 </a:tc>
               </a:tr>
-              <a:tr h="470262">
+              <a:tr h="548640">
                 <a:tc>
                   <a:txBody>
                     <a:bodyPr wrap="square"/>
@@ -2920,7 +3078,7 @@
                   </a:tcPr>
                 </a:tc>
               </a:tr>
-              <a:tr h="470262">
+              <a:tr h="548640">
                 <a:tc>
                   <a:txBody>
                     <a:bodyPr wrap="square"/>
@@ -3083,7 +3241,7 @@
                   </a:tcPr>
                 </a:tc>
               </a:tr>
-              <a:tr h="470262">
+              <a:tr h="548640">
                 <a:tc>
                   <a:txBody>
                     <a:bodyPr wrap="square"/>
@@ -3246,170 +3404,7 @@
                   </a:tcPr>
                 </a:tc>
               </a:tr>
-              <a:tr h="470262">
-                <a:tc>
-                  <a:txBody>
-                    <a:bodyPr wrap="square"/>
-                    <a:lstStyle/>
-                    <a:p>
-                      <a:pPr algn="l"/>
-                      <a:r>
-                        <a:rPr sz="1000">
-                          <a:solidFill>
-                            <a:srgbClr val="1F2937"/>
-                          </a:solidFill>
-                          <a:latin typeface="Calibri"/>
-                        </a:rPr>
-                        <a:t/>
-                      </a:r>
-                    </a:p>
-                  </a:txBody>
-                  <a:tcPr marL="54864" marR="54864" marT="18288" marB="18288">
-                    <a:solidFill>
-                      <a:srgbClr val="FFFFFF"/>
-                    </a:solidFill>
-                  </a:tcPr>
-                </a:tc>
-                <a:tc>
-                  <a:txBody>
-                    <a:bodyPr wrap="square"/>
-                    <a:lstStyle/>
-                    <a:p>
-                      <a:pPr algn="r"/>
-                      <a:r>
-                        <a:rPr sz="1000">
-                          <a:solidFill>
-                            <a:srgbClr val="1F2937"/>
-                          </a:solidFill>
-                          <a:latin typeface="Calibri"/>
-                        </a:rPr>
-                        <a:t/>
-                      </a:r>
-                    </a:p>
-                  </a:txBody>
-                  <a:tcPr marL="54864" marR="54864" marT="18288" marB="18288">
-                    <a:solidFill>
-                      <a:srgbClr val="FFFFFF"/>
-                    </a:solidFill>
-                  </a:tcPr>
-                </a:tc>
-                <a:tc>
-                  <a:txBody>
-                    <a:bodyPr wrap="square"/>
-                    <a:lstStyle/>
-                    <a:p>
-                      <a:pPr algn="r"/>
-                      <a:r>
-                        <a:rPr sz="1000">
-                          <a:solidFill>
-                            <a:srgbClr val="1F2937"/>
-                          </a:solidFill>
-                          <a:latin typeface="Calibri"/>
-                        </a:rPr>
-                        <a:t/>
-                      </a:r>
-                    </a:p>
-                  </a:txBody>
-                  <a:tcPr marL="54864" marR="54864" marT="18288" marB="18288">
-                    <a:solidFill>
-                      <a:srgbClr val="FFFFFF"/>
-                    </a:solidFill>
-                  </a:tcPr>
-                </a:tc>
-                <a:tc>
-                  <a:txBody>
-                    <a:bodyPr wrap="square"/>
-                    <a:lstStyle/>
-                    <a:p>
-                      <a:pPr algn="r"/>
-                      <a:r>
-                        <a:rPr sz="1000">
-                          <a:solidFill>
-                            <a:srgbClr val="1F2937"/>
-                          </a:solidFill>
-                          <a:latin typeface="Calibri"/>
-                        </a:rPr>
-                        <a:t/>
-                      </a:r>
-                    </a:p>
-                  </a:txBody>
-                  <a:tcPr marL="54864" marR="54864" marT="18288" marB="18288">
-                    <a:solidFill>
-                      <a:srgbClr val="FFFFFF"/>
-                    </a:solidFill>
-                  </a:tcPr>
-                </a:tc>
-                <a:tc>
-                  <a:txBody>
-                    <a:bodyPr wrap="square"/>
-                    <a:lstStyle/>
-                    <a:p>
-                      <a:pPr algn="r"/>
-                      <a:r>
-                        <a:rPr sz="1000">
-                          <a:solidFill>
-                            <a:srgbClr val="1F2937"/>
-                          </a:solidFill>
-                          <a:latin typeface="Calibri"/>
-                        </a:rPr>
-                        <a:t/>
-                      </a:r>
-                    </a:p>
-                  </a:txBody>
-                  <a:tcPr marL="54864" marR="54864" marT="18288" marB="18288">
-                    <a:solidFill>
-                      <a:srgbClr val="FFFFFF"/>
-                    </a:solidFill>
-                  </a:tcPr>
-                </a:tc>
-                <a:tc>
-                  <a:txBody>
-                    <a:bodyPr wrap="square"/>
-                    <a:lstStyle/>
-                    <a:p>
-                      <a:pPr algn="r"/>
-                      <a:r>
-                        <a:rPr sz="1000">
-                          <a:solidFill>
-                            <a:srgbClr val="1F2937"/>
-                          </a:solidFill>
-                          <a:latin typeface="Calibri"/>
-                        </a:rPr>
-                        <a:t/>
-                      </a:r>
-                    </a:p>
-                  </a:txBody>
-                  <a:tcPr marL="54864" marR="54864" marT="18288" marB="18288">
-                    <a:solidFill>
-                      <a:srgbClr val="FFFFFF"/>
-                    </a:solidFill>
-                  </a:tcPr>
-                </a:tc>
-                <a:tc>
-                  <a:txBody>
-                    <a:bodyPr wrap="square"/>
-                    <a:lstStyle/>
-                    <a:p>
-                      <a:pPr algn="l"/>
-                      <a:r>
-                        <a:rPr sz="1000">
-                          <a:solidFill>
-                            <a:srgbClr val="1F2937"/>
-                          </a:solidFill>
-                          <a:latin typeface="Calibri"/>
-                        </a:rPr>
-                        <a:t/>
-                      </a:r>
-                    </a:p>
-                  </a:txBody>
-                  <a:tcPr marL="54864" marR="54864" marT="18288" marB="18288">
-                    <a:solidFill>
-                      <a:srgbClr val="FFFFFF"/>
-                    </a:solidFill>
-                  </a:tcPr>
-                </a:tc>
-              </a:tr>
-              <a:tr h="470262">
+              <a:tr h="548640">
                 <a:tc>
                   <a:txBody>
                     <a:bodyPr wrap="square"/>

</xml_diff>